<commit_message>
sesuaikan path dan ganti istilah Inggris ke bahasa Indonesia
- perbarui semua path di SQL, notebook, Excel, laporan ke struktur baru
- kode pertanyaan Q1-Q5 menjadi P1-P5 di seluruh dokumen
- terjemahkan istilah Inggris di laporan (md/docx/pdf), presentasi, komentar SQL
- Excel: arahkan Power Query ke CSV baru, hapus kueri lama yang tidak terpakai,
  refresh ulang (7/7 metrik cocok)
- tambah 01_data_dan_pertanyaan/pertanyaan_bisnis.md dan 02_proses/README.md
- README utama ditulis ulang untuk pembaca klien
</commit_message>
<xml_diff>
--- a/03_hasil/presentasi_diagnosis_keterlambatan.pptx
+++ b/03_hasil/presentasi_diagnosis_keterlambatan.pptx
@@ -2691,7 +2691,7 @@
                 <a:ea typeface="Calibri" pitchFamily="34" charset="-122"/>
                 <a:cs typeface="Calibri" pitchFamily="34" charset="-120"/>
               </a:rPr>
-              <a:t>Disusun oleh Arif Herfian Zaen Chartiko (Operations Analyst) untuk Head of Logistics &amp; Fulfillment</a:t>
+              <a:t>Disusun oleh Arif Herfian Zaen Chartiko (Analis Operasional) untuk Kepala Divisi Logistik &amp; Pemenuhan Pesanan</a:t>
             </a:r>
             <a:endParaRPr lang="en-US" sz="1400" dirty="0"/>
           </a:p>
@@ -2775,7 +2775,7 @@
                 <a:ea typeface="Calibri" pitchFamily="34" charset="-122"/>
                 <a:cs typeface="Calibri" pitchFamily="34" charset="-120"/>
               </a:rPr>
-              <a:t>TEMUAN · Q4</a:t>
+              <a:t>TEMUAN · P4</a:t>
             </a:r>
             <a:endParaRPr lang="en-US" sz="1200" dirty="0"/>
           </a:p>
@@ -4007,7 +4007,7 @@
                 <a:ea typeface="Calibri" pitchFamily="34" charset="-122"/>
                 <a:cs typeface="Calibri" pitchFamily="34" charset="-120"/>
               </a:rPr>
-              <a:t>TEMUAN · Q5</a:t>
+              <a:t>TEMUAN · P5</a:t>
             </a:r>
             <a:endParaRPr lang="en-US" sz="1200" dirty="0"/>
           </a:p>
@@ -7356,7 +7356,7 @@
                 <a:ea typeface="Calibri" pitchFamily="34" charset="-122"/>
                 <a:cs typeface="Calibri" pitchFamily="34" charset="-120"/>
               </a:rPr>
-              <a:t>Hanya pesanan delivered dengan tanggal </a:t>
+              <a:t>Hanya pesanan terkirim dengan tanggal </a:t>
             </a:r>
             <a:r>
               <a:rPr lang="en-US" sz="950" dirty="0" err="1">
@@ -7787,7 +7787,7 @@
                 <a:ea typeface="Calibri" pitchFamily="34" charset="-122"/>
                 <a:cs typeface="Calibri" pitchFamily="34" charset="-120"/>
               </a:rPr>
-              <a:t> Q5. </a:t>
+              <a:t> P5. </a:t>
             </a:r>
             <a:r>
               <a:rPr lang="en-US" sz="950" dirty="0" err="1">
@@ -8741,7 +8741,7 @@
                 <a:ea typeface="Calibri" pitchFamily="34" charset="-122"/>
                 <a:cs typeface="Calibri" pitchFamily="34" charset="-120"/>
               </a:rPr>
-              <a:t>On-Time Delivery Rate</a:t>
+              <a:t>tingkat ketepatan waktu (OTD)</a:t>
             </a:r>
             <a:endParaRPr lang="en-US" sz="1100" dirty="0"/>
           </a:p>
@@ -9973,7 +9973,7 @@
                 <a:ea typeface="Calibri" pitchFamily="34" charset="-122"/>
                 <a:cs typeface="Calibri" pitchFamily="34" charset="-120"/>
               </a:rPr>
-              <a:t>saat</a:t>
+              <a:t>saat transaksi</a:t>
             </a:r>
             <a:r>
               <a:rPr lang="en-US" sz="1350" dirty="0">
@@ -9984,7 +9984,7 @@
                 <a:ea typeface="Calibri" pitchFamily="34" charset="-122"/>
                 <a:cs typeface="Calibri" pitchFamily="34" charset="-120"/>
               </a:rPr>
-              <a:t> checkout. Telat berarti tanggal terima aktual melewati tanggal janji tersebut.</a:t>
+              <a:t>. Telat berarti tanggal terima aktual melewati tanggal janji tersebut.</a:t>
             </a:r>
             <a:endParaRPr lang="en-US" sz="1350" dirty="0"/>
           </a:p>
@@ -10189,7 +10189,7 @@
                           <a:ea typeface="Calibri" pitchFamily="34" charset="-122"/>
                           <a:cs typeface="Calibri" pitchFamily="34" charset="-120"/>
                         </a:rPr>
-                        <a:t>Q1</a:t>
+                        <a:t>P1</a:t>
                       </a:r>
                       <a:endParaRPr lang="en-US" sz="1300" dirty="0">
                         <a:latin typeface="Calibri" charset="0"/>
@@ -10326,7 +10326,7 @@
                           <a:ea typeface="Calibri" pitchFamily="34" charset="-122"/>
                           <a:cs typeface="Calibri" pitchFamily="34" charset="-120"/>
                         </a:rPr>
-                        <a:t>Q2</a:t>
+                        <a:t>P2</a:t>
                       </a:r>
                       <a:endParaRPr lang="en-US" sz="1300" dirty="0">
                         <a:latin typeface="Calibri" charset="0"/>
@@ -10463,7 +10463,7 @@
                           <a:ea typeface="Calibri" pitchFamily="34" charset="-122"/>
                           <a:cs typeface="Calibri" pitchFamily="34" charset="-120"/>
                         </a:rPr>
-                        <a:t>Q3</a:t>
+                        <a:t>P3</a:t>
                       </a:r>
                       <a:endParaRPr lang="en-US" sz="1300" dirty="0">
                         <a:latin typeface="Calibri" charset="0"/>
@@ -10600,7 +10600,7 @@
                           <a:ea typeface="Calibri" pitchFamily="34" charset="-122"/>
                           <a:cs typeface="Calibri" pitchFamily="34" charset="-120"/>
                         </a:rPr>
-                        <a:t>Q4</a:t>
+                        <a:t>P4</a:t>
                       </a:r>
                       <a:endParaRPr lang="en-US" sz="1300" dirty="0">
                         <a:latin typeface="Calibri" charset="0"/>
@@ -10759,7 +10759,7 @@
                           <a:ea typeface="Calibri" pitchFamily="34" charset="-122"/>
                           <a:cs typeface="Calibri" pitchFamily="34" charset="-120"/>
                         </a:rPr>
-                        <a:t>Q5</a:t>
+                        <a:t>P5</a:t>
                       </a:r>
                       <a:endParaRPr lang="en-US" sz="1300" dirty="0">
                         <a:latin typeface="Calibri" charset="0"/>
@@ -11274,7 +11274,7 @@
                           <a:ea typeface="Calibri" pitchFamily="34" charset="-122"/>
                           <a:cs typeface="Calibri" pitchFamily="34" charset="-120"/>
                         </a:rPr>
-                        <a:t>PostgreSQL, view analytics.fact_order_delivery</a:t>
+                        <a:t>PostgreSQL, tabel analisis pesanan</a:t>
                       </a:r>
                       <a:endParaRPr lang="en-US" sz="1100" dirty="0">
                         <a:latin typeface="Calibri" charset="0"/>
@@ -11685,7 +11685,7 @@
                           <a:ea typeface="Calibri" pitchFamily="34" charset="-122"/>
                           <a:cs typeface="Calibri" pitchFamily="34" charset="-120"/>
                         </a:rPr>
-                        <a:t>Hanya status delivered, tanggal terima terisi</a:t>
+                        <a:t>Hanya status terkirim, tanggal terima terisi</a:t>
                       </a:r>
                       <a:endParaRPr lang="en-US" sz="1100" dirty="0">
                         <a:latin typeface="Calibri" charset="0"/>
@@ -12546,7 +12546,7 @@
                 <a:ea typeface="Calibri" pitchFamily="34" charset="-122"/>
                 <a:cs typeface="Calibri" pitchFamily="34" charset="-120"/>
               </a:rPr>
-              <a:t>19 pesanan tercatat diterima pelanggan lebih dulu daripada diserahkan ke kurir — mustahil secara fisik. Pesanan ini ditandai has_sequence_anomaly dan dikeluarkan dari </a:t>
+              <a:t>19 pesanan tercatat diterima pelanggan lebih dulu daripada diserahkan ke kurir — mustahil secara fisik. Pesanan ini ditandai sebagai anomali dan dikeluarkan dari </a:t>
             </a:r>
             <a:r>
               <a:rPr lang="en-US" sz="1150" dirty="0" err="1">
@@ -12758,7 +12758,7 @@
                 <a:ea typeface="Calibri" pitchFamily="34" charset="-122"/>
                 <a:cs typeface="Calibri" pitchFamily="34" charset="-120"/>
               </a:rPr>
-              <a:t>TEMUAN · Q1</a:t>
+              <a:t>TEMUAN · P1</a:t>
             </a:r>
             <a:endParaRPr lang="en-US" sz="1200" dirty="0"/>
           </a:p>
@@ -13692,7 +13692,7 @@
                 <a:ea typeface="Calibri" pitchFamily="34" charset="-122"/>
                 <a:cs typeface="Calibri" pitchFamily="34" charset="-120"/>
               </a:rPr>
-              <a:t>Terjadi pada volume normal, namun lebih parah dari Nov 2017. Penyebabnya harus dicari di tempat lain (lihat Q2).</a:t>
+              <a:t>Terjadi pada volume normal, namun lebih parah dari Nov 2017. Penyebabnya harus dicari di tempat lain (lihat P2).</a:t>
             </a:r>
             <a:endParaRPr lang="en-US" sz="1150" dirty="0"/>
           </a:p>
@@ -13815,7 +13815,7 @@
                 <a:ea typeface="Calibri" pitchFamily="34" charset="-122"/>
                 <a:cs typeface="Calibri" pitchFamily="34" charset="-120"/>
               </a:rPr>
-              <a:t>TEMUAN · Q2</a:t>
+              <a:t>TEMUAN · P2</a:t>
             </a:r>
             <a:endParaRPr lang="en-US" sz="1200" dirty="0"/>
           </a:p>
@@ -15286,7 +15286,7 @@
                 <a:ea typeface="Calibri" pitchFamily="34" charset="-122"/>
                 <a:cs typeface="Calibri" pitchFamily="34" charset="-120"/>
               </a:rPr>
-              <a:t>TEMUAN · Q2 (LANJUTAN)</a:t>
+              <a:t>TEMUAN · P2 (LANJUTAN)</a:t>
             </a:r>
             <a:endParaRPr lang="en-US" sz="1200" dirty="0"/>
           </a:p>
@@ -17250,7 +17250,7 @@
                 <a:ea typeface="Calibri" pitchFamily="34" charset="-122"/>
                 <a:cs typeface="Calibri" pitchFamily="34" charset="-120"/>
               </a:rPr>
-              <a:t>TEMUAN · Q3</a:t>
+              <a:t>TEMUAN · P3</a:t>
             </a:r>
             <a:endParaRPr lang="en-US" sz="1200" dirty="0"/>
           </a:p>
@@ -18309,7 +18309,7 @@
                 <a:ea typeface="Calibri" pitchFamily="34" charset="-122"/>
                 <a:cs typeface="Calibri" pitchFamily="34" charset="-120"/>
               </a:rPr>
-              <a:t>TEMUAN · Q3 (LANJUTAN)</a:t>
+              <a:t>TEMUAN · P3 (LANJUTAN)</a:t>
             </a:r>
             <a:endParaRPr lang="en-US" sz="1200" dirty="0"/>
           </a:p>

</xml_diff>

<commit_message>
kembalikan nama teknis PostgreSQL di slide presentasi
Nama view dan status ditulis persis (analytics.fact_order_delivery, delivered)
dengan penjelasan bahasa Indonesia, sama seperti di laporan, supaya bisa
dicocokkan langsung dengan database.
</commit_message>
<xml_diff>
--- a/03_hasil/presentasi_diagnosis_keterlambatan.pptx
+++ b/03_hasil/presentasi_diagnosis_keterlambatan.pptx
@@ -7356,7 +7356,7 @@
                 <a:ea typeface="Calibri" pitchFamily="34" charset="-122"/>
                 <a:cs typeface="Calibri" pitchFamily="34" charset="-120"/>
               </a:rPr>
-              <a:t>Hanya pesanan terkirim dengan tanggal </a:t>
+              <a:t>Hanya pesanan terkirim (delivered) dengan tanggal </a:t>
             </a:r>
             <a:r>
               <a:rPr lang="en-US" sz="950" dirty="0" err="1">
@@ -11274,7 +11274,7 @@
                           <a:ea typeface="Calibri" pitchFamily="34" charset="-122"/>
                           <a:cs typeface="Calibri" pitchFamily="34" charset="-120"/>
                         </a:rPr>
-                        <a:t>PostgreSQL, tabel analisis pesanan</a:t>
+                        <a:t>PostgreSQL, tabel analisis analytics.fact_order_delivery</a:t>
                       </a:r>
                       <a:endParaRPr lang="en-US" sz="1100" dirty="0">
                         <a:latin typeface="Calibri" charset="0"/>
@@ -11685,7 +11685,7 @@
                           <a:ea typeface="Calibri" pitchFamily="34" charset="-122"/>
                           <a:cs typeface="Calibri" pitchFamily="34" charset="-120"/>
                         </a:rPr>
-                        <a:t>Hanya status terkirim, tanggal terima terisi</a:t>
+                        <a:t>Hanya status terkirim (delivered), tanggal terima terisi</a:t>
                       </a:r>
                       <a:endParaRPr lang="en-US" sz="1100" dirty="0">
                         <a:latin typeface="Calibri" charset="0"/>

</xml_diff>